<commit_message>
Clase 2: ajustar material a la clase 1 sin JUnit
La clase 1 ahora es Java puro con gradle run. La guía de estudio, el
README, la presentación y la actividad ya no dan por sabido JUnit ni
PASSED/FAILED: los explican en una línea. La guía docente (fuera del
repo) revisa en la retroalimentación la salida de gradle run con los
4 casos de la clase Tienda.

Co-Authored-By: Claude Opus 5 (1M context) <noreply@anthropic.com>
Claude-Session: https://claude.ai/code/session_01L2JuF1iG72koPJkmuRWSzm
</commit_message>
<xml_diff>
--- a/material-de-apoyo/Clase2_Presentacion_Screenplay_Web.pptx
+++ b/material-de-apoyo/Clase2_Presentacion_Screenplay_Web.pptx
@@ -9264,7 +9264,7 @@
                 </a:solidFill>
                 <a:latin typeface="Century Gothic"/>
               </a:rPr>
-              <a:t> es verde, </a:t>
+              <a:t>: la prueba pasó. </a:t>
             </a:r>
             <a:r>
               <a:rPr b="0" sz="1600">
@@ -9282,7 +9282,7 @@
                 </a:solidFill>
                 <a:latin typeface="Century Gothic"/>
               </a:rPr>
-              <a:t> es rojo.</a:t>
+              <a:t>: falló.</a:t>
             </a:r>
           </a:p>
           <a:p>

</xml_diff>